<commit_message>
Regenerative post: sunny flowers version with logo top right, PNG and editable PPTX
Co-Authored-By: Claude Opus 5.5 <noreply@anthropic.com>
Claude-Session: https://claude.ai/code/session_01Mm2WQWuqhG5pSCHMfFzovJ
</commit_message>
<xml_diff>
--- a/social/regenerative-2026-10-15/sunny-3/regenerative-sunny-3-canva.pptx
+++ b/social/regenerative-2026-10-15/sunny-3/regenerative-sunny-3-canva.pptx
@@ -3114,7 +3114,7 @@
       </p:pic>
       <p:pic>
         <p:nvPicPr>
-          <p:cNvPr id="3" name="flower-cornflower" descr="s1-04-flower-cornflower.png"/>
+          <p:cNvPr id="3" name="logo" descr="s1-02-logo.png"/>
           <p:cNvPicPr>
             <a:picLocks noChangeAspect="1"/>
           </p:cNvPicPr>
@@ -3122,6 +3122,30 @@
         </p:nvPicPr>
         <p:blipFill>
           <a:blip r:embed="rId3"/>
+          <a:stretch>
+            <a:fillRect/>
+          </a:stretch>
+        </p:blipFill>
+        <p:spPr>
+          <a:xfrm>
+            <a:off x="7010400" y="541867"/>
+            <a:ext cx="1524000" cy="1320800"/>
+          </a:xfrm>
+          <a:prstGeom prst="rect">
+            <a:avLst/>
+          </a:prstGeom>
+        </p:spPr>
+      </p:pic>
+      <p:pic>
+        <p:nvPicPr>
+          <p:cNvPr id="4" name="flower-cornflower" descr="s1-05-flower-cornflower.png"/>
+          <p:cNvPicPr>
+            <a:picLocks noChangeAspect="1"/>
+          </p:cNvPicPr>
+          <p:nvPr/>
+        </p:nvPicPr>
+        <p:blipFill>
+          <a:blip r:embed="rId4"/>
           <a:stretch>
             <a:fillRect/>
           </a:stretch>
@@ -3138,14 +3162,14 @@
       </p:pic>
       <p:pic>
         <p:nvPicPr>
-          <p:cNvPr id="4" name="flower-marigold" descr="s1-05-flower-marigold.png"/>
+          <p:cNvPr id="5" name="flower-marigold" descr="s1-06-flower-marigold.png"/>
           <p:cNvPicPr>
             <a:picLocks noChangeAspect="1"/>
           </p:cNvPicPr>
           <p:nvPr/>
         </p:nvPicPr>
         <p:blipFill>
-          <a:blip r:embed="rId4"/>
+          <a:blip r:embed="rId5"/>
           <a:stretch>
             <a:fillRect/>
           </a:stretch>
@@ -3162,14 +3186,14 @@
       </p:pic>
       <p:pic>
         <p:nvPicPr>
-          <p:cNvPr id="5" name="flower-paintbrush" descr="s1-06-flower-paintbrush.png"/>
+          <p:cNvPr id="6" name="flower-paintbrush" descr="s1-07-flower-paintbrush.png"/>
           <p:cNvPicPr>
             <a:picLocks noChangeAspect="1"/>
           </p:cNvPicPr>
           <p:nvPr/>
         </p:nvPicPr>
         <p:blipFill>
-          <a:blip r:embed="rId5"/>
+          <a:blip r:embed="rId6"/>
           <a:stretch>
             <a:fillRect/>
           </a:stretch>
@@ -3186,14 +3210,14 @@
       </p:pic>
       <p:pic>
         <p:nvPicPr>
-          <p:cNvPr id="6" name="flower-hibiscus" descr="s1-07-flower-hibiscus.png"/>
+          <p:cNvPr id="7" name="flower-hibiscus" descr="s1-08-flower-hibiscus.png"/>
           <p:cNvPicPr>
             <a:picLocks noChangeAspect="1"/>
           </p:cNvPicPr>
           <p:nvPr/>
         </p:nvPicPr>
         <p:blipFill>
-          <a:blip r:embed="rId6"/>
+          <a:blip r:embed="rId7"/>
           <a:stretch>
             <a:fillRect/>
           </a:stretch>
@@ -3210,14 +3234,14 @@
       </p:pic>
       <p:pic>
         <p:nvPicPr>
-          <p:cNvPr id="7" name="flower-chamisa" descr="s1-08-flower-chamisa.png"/>
+          <p:cNvPr id="8" name="flower-chamisa" descr="s1-09-flower-chamisa.png"/>
           <p:cNvPicPr>
             <a:picLocks noChangeAspect="1"/>
           </p:cNvPicPr>
           <p:nvPr/>
         </p:nvPicPr>
         <p:blipFill>
-          <a:blip r:embed="rId7"/>
+          <a:blip r:embed="rId8"/>
           <a:stretch>
             <a:fillRect/>
           </a:stretch>
@@ -3234,14 +3258,14 @@
       </p:pic>
       <p:pic>
         <p:nvPicPr>
-          <p:cNvPr id="8" name="flower-heliconia" descr="s1-09-flower-heliconia.png"/>
+          <p:cNvPr id="9" name="flower-heliconia" descr="s1-10-flower-heliconia.png"/>
           <p:cNvPicPr>
             <a:picLocks noChangeAspect="1"/>
           </p:cNvPicPr>
           <p:nvPr/>
         </p:nvPicPr>
         <p:blipFill>
-          <a:blip r:embed="rId8"/>
+          <a:blip r:embed="rId9"/>
           <a:stretch>
             <a:fillRect/>
           </a:stretch>
@@ -3258,14 +3282,14 @@
       </p:pic>
       <p:pic>
         <p:nvPicPr>
-          <p:cNvPr id="9" name="flower-cornflower-2" descr="s1-10-flower-cornflower-2.png"/>
+          <p:cNvPr id="10" name="flower-cornflower-2" descr="s1-11-flower-cornflower-2.png"/>
           <p:cNvPicPr>
             <a:picLocks noChangeAspect="1"/>
           </p:cNvPicPr>
           <p:nvPr/>
         </p:nvPicPr>
         <p:blipFill>
-          <a:blip r:embed="rId9"/>
+          <a:blip r:embed="rId10"/>
           <a:stretch>
             <a:fillRect/>
           </a:stretch>
@@ -3282,7 +3306,7 @@
       </p:pic>
       <p:sp>
         <p:nvSpPr>
-          <p:cNvPr id="10" name="headline"/>
+          <p:cNvPr id="11" name="headline"/>
           <p:cNvSpPr txBox="1"/>
           <p:nvPr/>
         </p:nvSpPr>
@@ -3321,7 +3345,7 @@
       </p:sp>
       <p:sp>
         <p:nvSpPr>
-          <p:cNvPr id="11" name="small-line"/>
+          <p:cNvPr id="12" name="small-line"/>
           <p:cNvSpPr txBox="1"/>
           <p:nvPr/>
         </p:nvSpPr>

</xml_diff>